<commit_message>
refactor(lecture-03): remove all references to unscheduled lab works across figures, slides, speech, and plan
</commit_message>
<xml_diff>
--- a/course_materials/semester_4/lectures/lecture_03_colloids.pptx
+++ b/course_materials/semester_4/lectures/lecture_03_colloids.pptx
@@ -518,7 +518,7 @@
           <a:lstStyle/>
           <a:p>
             <a:r>
-              <a:t>1. Живая завязка: На прошлой лекции мы выяснили, что одиночная наночастица переполнена поверхностной энергией ΔG_s = σS &gt; 0. Если налить в стакан триллионы таких частиц (как в ЛР №2 и №3), термодинамика требует их мгновенного слипания!</a:t>
+              <a:t>1. Живая завязка: На прошлой лекции мы выяснили, что одиночная наночастица переполнена поверхностной энергией ΔG_s = σS &gt; 0. Если налить в стакан триллионы таких частиц (гидрозоль золота или гидроксида железа), термодинамика требует их мгновенного слипания!</a:t>
             </a:r>
           </a:p>
           <a:p>
@@ -528,7 +528,7 @@
           </a:p>
           <a:p>
             <a:r>
-              <a:t>3. Четыре навыка: Сегодня мы получим 4 конкретных инженерных инструмента — от конструктора мицеллы за 4 шага до расчета порога коагуляции в ЛР №3.</a:t>
+              <a:t>3. Четыре навыка: Сегодня мы получим 4 конкретных инженерных инструмента — от конструктора мицеллы за 4 шага до расчета порога коагуляции электролитами.</a:t>
             </a:r>
           </a:p>
         </p:txBody>
@@ -898,12 +898,12 @@
           <a:lstStyle/>
           <a:p>
             <a:r>
-              <a:t>1. Загадка золота в ЛР №2: Золото почти в 20 раз тяжелее воды, но ваш рубиновый золь (r = 7.5 нм, синяя кривая) абсолютно однороден по высоте пробирки!</a:t>
-            </a:r>
-          </a:p>
-          <a:p>
-            <a:r>
-              <a:t>2. Сила куба радиуса (1/r³): Стоит частицам потерять заряд и слипнуться всего в 4 раза по радиусу (с 7.5 до 30 нм, красная кривая), как куб радиуса r³ вырастает в 4³ = 64 раза! Тепловое движение проигрывает, и золото камнем падает на дно. Значит, главное — не дать частицам слипнуться!</a:t>
+              <a:t>1. Загадка коллоидного золота: Золото почти в 20 раз тяжелее воды, но рубиновый гидрозоль (r = 5 нм, синяя кривая) абсолютно однороден по высоте пробирки!</a:t>
+            </a:r>
+          </a:p>
+          <a:p>
+            <a:r>
+              <a:t>2. Сила куба радиуса (1/r³): Стоит частицам потерять заряд и слипнуться всего в 3 раза по радиусу (с 5 до 16 нм, красная кривая), как куб радиуса r³ вырастает в 3.2³ ≈ 33 раза! Тепловое движение проигрывает, и золото камнем падает на дно. Значит, главное — не дать частицам слипнуться!</a:t>
             </a:r>
           </a:p>
         </p:txBody>
@@ -1053,7 +1053,7 @@
           </a:p>
           <a:p>
             <a:r>
-              <a:t>2. Две главные ловушки на защите ЛР №3: (1) Почему везде калий K⁺? Чтобы доказать, что одноименный ион не влияет, а работают только анионы-противоионы! (2) Не забывайте прибавлять V_эл к V_золя в знаменателе при расчете γ_кр.</a:t>
+              <a:t>2. Две главные ловушки в расчетных задачах: (1) Почему везде калий K⁺? Чтобы доказать, что одноименный ион не влияет, а работают только анионы-противоионы! (2) Не забывайте прибавлять V_эл к V_золя в знаменателе при расчете γ_кр.</a:t>
             </a:r>
           </a:p>
         </p:txBody>
@@ -1128,12 +1128,12 @@
           </a:p>
           <a:p>
             <a:r>
-              <a:t>2. Чек-лист к защите ЛР №2 и №3: Во второй карточке и на схеме справа собраны прямые ответы на вопросы при приеме лабораторных работ.</a:t>
-            </a:r>
-          </a:p>
-          <a:p>
-            <a:r>
-              <a:t>3. Мостик к Лекции №4: Через две недели переходим к поверхностному натяжению, изотермам адсорбции Ленгмюра и БЭТ и трем механизмам эпитаксиального роста нанопленок.</a:t>
+              <a:t>2. Чек-лист к зачету: Во второй карточке и на схеме справа собраны прямые ответы на ключевые контрольные вопросы по теме.</a:t>
+            </a:r>
+          </a:p>
+          <a:p>
+            <a:r>
+              <a:t>3. Мостик к Лекции №4: На следующей лекции переходим к поверхностному натяжению, изотермам адсорбции Ленгмюра и БЭТ и трем механизмам эпитаксиального роста нанопленок.</a:t>
             </a:r>
           </a:p>
         </p:txBody>
@@ -1293,7 +1293,7 @@
           </a:p>
           <a:p>
             <a:r>
-              <a:t>3. Связь с практикумом в таблице 3×3: Ячейка Т/Ж — это гидрозоли в ЛР №1–3; ячейка Г/Т — это твердые пористые матрицы Si и Al₂O₃ в ЛР №4–5.</a:t>
+              <a:t>3. Примеры в таблице 3×3: Ячейка Т/Ж — это плазмонные гидрозоли Ag, Au и золь Fe(OH)₃; ячейка Г/Т — твердые нанопористые матрицы (аэрогели, цеолиты, пористый Si и Al₂O₃).</a:t>
             </a:r>
           </a:p>
         </p:txBody>
@@ -1528,7 +1528,7 @@
           </a:p>
           <a:p>
             <a:r>
-              <a:t>2. Главная ловушка на защите ЛР №3: «Какой заряд у мицеллы?» Правильный ответ: НУЛЕВОЙ! Заряжена только ГРАНУЛА (то, что внутри фигурных скобок), а вся мицелла электронейтральна.</a:t>
+              <a:t>2. Главная ловушка на зачете: «Какой заряд у мицеллы?» Правильный ответ: НУЛЕВОЙ! Заряжена только ГРАНУЛА (то, что внутри фигурных скобок), а вся мицелла электронейтральна.</a:t>
             </a:r>
           </a:p>
         </p:txBody>
@@ -1603,12 +1603,12 @@
           </a:p>
           <a:p>
             <a:r>
-              <a:t>2. Разбор ЛР №3 (карточка 2): Эту формулу спрашивают у каждого! Осадок Fe(OH)₃, стабилизатор FeOCl, потенциалопределяющий ион — катион оксожелеза FeO⁺ (или Fe³⁺), противоионы — хлориды Cl⁻.</a:t>
-            </a:r>
-          </a:p>
-          <a:p>
-            <a:r>
-              <a:t>3. Ключ к титрованию в ЛР №3: Раз гранула заряжена плюсом (x+), то осаждать (коагулировать) ее будут отрицательные ионы (анионы) добавляемых солей!</a:t>
+              <a:t>2. Разбор золя Fe(OH)₃ (карточка 2): Классическая учебная задача! Осадок Fe(OH)₃, стабилизатор FeOCl, потенциалопределяющий ион — катион оксожелеза FeO⁺ (или Fe³⁺), противоионы — хлориды Cl⁻.</a:t>
+            </a:r>
+          </a:p>
+          <a:p>
+            <a:r>
+              <a:t>3. Ключ к задачам на коагуляцию: Раз гранула заряжена плюсом (x+), то осаждать (коагулировать) ее будут отрицательные ионы (анионы) добавляемых солей!</a:t>
             </a:r>
           </a:p>
         </p:txBody>
@@ -4963,7 +4963,7 @@
               </a:defRPr>
             </a:pPr>
             <a:r>
-              <a:t>• Почему же нанозоль золота (ЛР №2) стоит годами без осадка? Его защищает двойной электрический слой (ДЭС).</a:t>
+              <a:t>• Почему же рубиновый нанозоль золота стоит годами без осадка? Его защищает двойной электрический слой (ДЭС).</a:t>
             </a:r>
           </a:p>
         </p:txBody>
@@ -5021,7 +5021,7 @@
               </a:defRPr>
             </a:pPr>
             <a:r>
-              <a:t>2. Четыре практических навыка лекции (ЛР №2 и №3)</a:t>
+              <a:t>2. Четыре практических навыка лекции</a:t>
             </a:r>
           </a:p>
           <a:p>
@@ -5069,7 +5069,7 @@
               </a:defRPr>
             </a:pPr>
             <a:r>
-              <a:t>• Навык 3: Применить правило 6-й степени (1 : 1/64 : 1/729) в ЛР №3.</a:t>
+              <a:t>• Навык 3: Применить правило 6-й степени (1 : 1/64 : 1/729) для коагуляции.</a:t>
             </a:r>
           </a:p>
           <a:p>
@@ -6008,7 +6008,7 @@
               </a:defRPr>
             </a:pPr>
             <a:r>
-              <a:t>• |ζ| &gt; 30 мВ — СТАБИЛЬНЫЙ ЗОЛЬ! Частицы сильно отталкиваются (у цитратного золя золота в ЛР №2 ζ ≈ −40 мВ).</a:t>
+              <a:t>• |ζ| &gt; 30 мВ — СТАБИЛЬНЫЙ ЗОЛЬ! Частицы сильно отталкиваются (у цитратного золя золота ζ ≈ −40 мВ).</a:t>
             </a:r>
           </a:p>
           <a:p>
@@ -7590,7 +7590,7 @@
               </a:defRPr>
             </a:pPr>
             <a:r>
-              <a:t>Ключевой вывод: За счет зависимости h_e ∝ r⁻³ наночастицы золота (r ≤ 10 нм в ЛР №2) седиментационно абсолютно устойчивы, пока не произойдет их агрегация!</a:t>
+              <a:t>Ключевой вывод: За счет зависимости h_e ∝ r⁻³ наночастицы золота (r ≤ 10 нм) седиментационно абсолютно устойчивы, пока не произойдет их агрегация!</a:t>
             </a:r>
           </a:p>
         </p:txBody>
@@ -8150,7 +8150,7 @@
               </a:defRPr>
             </a:pPr>
             <a:r>
-              <a:t>Блок 4. Порог коагуляции γ_кр и расчеты в Лабораторной работе №3 (Навык №3)</a:t>
+              <a:t>Блок 4. Порог коагуляции γ_кр и методика решения задач на коагуляцию (Навык №3)</a:t>
             </a:r>
           </a:p>
         </p:txBody>
@@ -8360,7 +8360,7 @@
               </a:defRPr>
             </a:pPr>
             <a:r>
-              <a:t>2. Шпаргалка и ловушки к защите ЛР №3 (золь Fe(OH)₃)</a:t>
+              <a:t>2. Алгоритм и ловушки в задачах на коагуляцию (золь Fe(OH)₃)</a:t>
             </a:r>
           </a:p>
           <a:p>
@@ -8592,7 +8592,7 @@
               </a:defRPr>
             </a:pPr>
             <a:r>
-              <a:t>Итоги лекции №3 и чек-лист к защите Лабораторных работ №2 и №3</a:t>
+              <a:t>Итоги лекции №3 и разбор двух эталонных коллоидных наносистем</a:t>
             </a:r>
           </a:p>
           <a:p>
@@ -8812,7 +8812,7 @@
               </a:defRPr>
             </a:pPr>
             <a:r>
-              <a:t>2. Чек-лист: 3 вопроса на защите ЛР №2 и №3</a:t>
+              <a:t>2. Чек-лист: 3 главных вопроса к зачету по коллоидным системам</a:t>
             </a:r>
           </a:p>
           <a:p>
@@ -8828,7 +8828,7 @@
               </a:defRPr>
             </a:pPr>
             <a:r>
-              <a:t>• ЛР №2: Почему красный золь Au (520 нм) синеет от соли? → Соль сжимает ДЭС, барьер падает, частицы слипаются!</a:t>
+              <a:t>• Вопрос 1: Почему рубиновый золь Au (520 нм) синеет от соли? → Соль сжимает ДЭС, барьер падает, частицы слипаются!</a:t>
             </a:r>
           </a:p>
           <a:p>
@@ -8844,7 +8844,7 @@
               </a:defRPr>
             </a:pPr>
             <a:r>
-              <a:t>• ЛР №3: Каков заряд мицеллы Fe(OH)₃? → Мицелла нейтральна (0), а ГРАНУЛА заряжена «+» (ПОИ — катион FeO⁺)!</a:t>
+              <a:t>• Вопрос 2: Каков заряд мицеллы Fe(OH)₃? → Мицелла нейтральна (0), а ГРАНУЛА заряжена «+» (ПОИ — катион FeO⁺)!</a:t>
             </a:r>
           </a:p>
           <a:p>
@@ -8860,7 +8860,7 @@
               </a:defRPr>
             </a:pPr>
             <a:r>
-              <a:t>• ЛР №3: Как относятся пороги коагуляции Cl⁻, SO₄²⁻, [Fe(CN)₆]³⁻? → По закону 6-й степени (z⁻⁶): 1 : 1/64 : 1/729.</a:t>
+              <a:t>• Вопрос 3: Как относятся пороги коагуляции Cl⁻, SO₄²⁻, [Fe(CN)₆]³⁻? → По закону 6-й степени (z⁻⁶): 1 : 1/64 : 1/729.</a:t>
             </a:r>
           </a:p>
           <a:p>
@@ -8942,8 +8942,8 @@
         </p:blipFill>
         <p:spPr>
           <a:xfrm>
-            <a:off x="5626047" y="1216152"/>
-            <a:ext cx="5966056" cy="4562856"/>
+            <a:off x="5597836" y="1216152"/>
+            <a:ext cx="6022479" cy="4562856"/>
           </a:xfrm>
           <a:prstGeom prst="rect">
             <a:avLst/>
@@ -9000,7 +9000,7 @@
               </a:defRPr>
             </a:pPr>
             <a:r>
-              <a:t>Ключевой вывод: Теория ДЭС и ДЛФО соединяет фундаментальную термодинамику с практикой: от стабилизации плазмонных наночастиц золота (ЛР №2) до управляемой коагуляции золя Fe(OH)₃ (ЛР №3).</a:t>
+              <a:t>Ключевой вывод: Теория ДЭС и ДЛФО соединяет фундаментальную термодинамику с практикой: от стабилизации плазмонных наночастиц золота до управляемой коагуляции гидрозоля Fe(OH)₃.</a:t>
             </a:r>
           </a:p>
         </p:txBody>
@@ -9964,8 +9964,8 @@
         </p:blipFill>
         <p:spPr>
           <a:xfrm>
-            <a:off x="5570912" y="1216152"/>
-            <a:ext cx="6076327" cy="4562856"/>
+            <a:off x="5589612" y="1216152"/>
+            <a:ext cx="6038927" cy="4562856"/>
           </a:xfrm>
           <a:prstGeom prst="rect">
             <a:avLst/>
@@ -11464,7 +11464,7 @@
               </a:defRPr>
             </a:pPr>
             <a:r>
-              <a:t>Формулы мицелл: перезарядка золя AgI и гидрозоль Fe(OH)₃ (ЛР №3)</a:t>
+              <a:t>Формулы мицелл: перезарядка золя AgI и гидрозоль Fe(OH)₃</a:t>
             </a:r>
           </a:p>
           <a:p>
@@ -11722,7 +11722,7 @@
               </a:defRPr>
             </a:pPr>
             <a:r>
-              <a:t>2. Золь Fe(OH)₃ в кипящей воде — объект вашей ЛР №3</a:t>
+              <a:t>2. Классический золь Fe(OH)₃ при гидролизе в кипящей воде</a:t>
             </a:r>
           </a:p>
           <a:p>
@@ -11855,8 +11855,8 @@
         </p:blipFill>
         <p:spPr>
           <a:xfrm>
-            <a:off x="5559552" y="1595182"/>
-            <a:ext cx="6099048" cy="3804794"/>
+            <a:off x="5559552" y="1564127"/>
+            <a:ext cx="6099048" cy="3866905"/>
           </a:xfrm>
           <a:prstGeom prst="rect">
             <a:avLst/>
@@ -11913,7 +11913,7 @@
               </a:defRPr>
             </a:pPr>
             <a:r>
-              <a:t>Ключевой вывод: В ЛР №3 гранула золя Fe(OH)₃ заряжена ПОЛОЖИТЕЛЬНО за счет адсорбции катионов FeO⁺, поэтому коагуляцию этого золя вызывают АНИОНЫ электролита!</a:t>
+              <a:t>Ключевой вывод: Гранула гидрозоля Fe(OH)₃ заряжена ПОЛОЖИТЕЛЬНО за счет адсорбции катионов FeO⁺, поэтому коагуляцию этого золя вызывают АНИОНЫ электролита!</a:t>
             </a:r>
           </a:p>
         </p:txBody>

</xml_diff>